<commit_message>
AML model comparison, final report and slides
Co-authored-by: Cursor <cursoragent@cursor.com>
</commit_message>
<xml_diff>
--- a/docs/presentation.pptx
+++ b/docs/presentation.pptx
@@ -119,21 +119,21 @@
   <p:extLst>
     <p:ext uri="{521415D9-36F7-43E2-AB2F-B90AF26B5E84}">
       <p14:sectionLst xmlns:p14="http://schemas.microsoft.com/office/powerpoint/2010/main">
-        <p14:section name="Introduction" id="{887fc22a-6e3d-c257-c6e8-11fff9cc33eb}">
+        <p14:section name="Introduction" id="{3961ea12-7230-f615-0ed6-813f81a8cf0d}">
           <p14:sldIdLst>
             <p14:sldId id="256"/>
             <p14:sldId id="257"/>
             <p14:sldId id="258"/>
           </p14:sldIdLst>
         </p14:section>
-        <p14:section name="Method" id="{24a33b4e-44ac-01ec-3d86-d658d0df36ac}">
+        <p14:section name="Method" id="{980b7e14-47ec-75f0-89c7-81271f271dd7}">
           <p14:sldIdLst>
             <p14:sldId id="259"/>
             <p14:sldId id="260"/>
             <p14:sldId id="261"/>
           </p14:sldIdLst>
         </p14:section>
-        <p14:section name="Results" id="{46f51ba5-17b8-f6a2-8b0d-6f8120e970a7}">
+        <p14:section name="Results" id="{0294756e-8d23-5f9e-b170-54fc3b561afc}">
           <p14:sldIdLst>
             <p14:sldId id="262"/>
             <p14:sldId id="263"/>
@@ -1540,7 +1540,7 @@
             <a:r>
               <a:rPr lang="en-US" dirty="0"/>
               <a:t>Presenter: Divya Singh
-Duration: each phoneme is one example; LightGBM uses the phoneme, its neighbours, stress, position and whether a pause follows, and cuts error by a third versus a per-phoneme average. Pauses: for every word gap we predict pause or no pause from text only; the classifier finds nine points more real pauses than the punctuation rule at the same 68% precision.</a:t>
+We compared five model families on the same features and split. For duration, LightGBM is significantly better than every alternative; the linear model is 7.7 ms worse, so duration depends on interactions, for example a vowel stretching more when it is stressed and before a pause. Random forest and the MLP come close but were trained on a 200k subsample. Tuning found slightly larger trees 0.3 ms better, small next to model choice. Ablation: removing the neighbouring phonemes hurts most (+5.7 ms), even more than the phoneme itself; the following-pause flag adds nothing because the next-phoneme feature already encodes it. For pauses, every learned model beats the punctuation rule; the non-linear models are within about one F1 point, LightGBM highest. Only 56% of long pauses follow punctuation.</a:t>
             </a:r>
             <a:endParaRPr lang="en-US" dirty="0"/>
           </a:p>
@@ -7183,7 +7183,7 @@
         <p:spPr>
           <a:xfrm>
             <a:off x="685800" y="1463040"/>
-            <a:ext cx="3566160" cy="228600"/>
+            <a:ext cx="3749040" cy="228600"/>
           </a:xfrm>
           <a:prstGeom prst="rect">
             <a:avLst/>
@@ -7207,87 +7207,9 @@
                 <a:ea typeface="Calibri" pitchFamily="34" charset="-122"/>
                 <a:cs typeface="Calibri" pitchFamily="34" charset="-120"/>
               </a:rPr>
-              <a:t>DURATION</a:t>
+              <a:t>DURATION  ·  MAE ON SPEECH SOUNDS</a:t>
             </a:r>
             <a:endParaRPr lang="en-US" sz="900" dirty="0"/>
-          </a:p>
-        </p:txBody>
-      </p:sp>
-      <p:sp>
-        <p:nvSpPr>
-          <p:cNvPr id="5" name="Text 3"/>
-          <p:cNvSpPr txBox="1"/>
-          <p:nvPr/>
-        </p:nvSpPr>
-        <p:spPr>
-          <a:xfrm>
-            <a:off x="685800" y="1600200"/>
-            <a:ext cx="3566160" cy="914400"/>
-          </a:xfrm>
-          <a:prstGeom prst="rect">
-            <a:avLst/>
-          </a:prstGeom>
-          <a:noFill/>
-          <a:ln/>
-        </p:spPr>
-        <p:txBody>
-          <a:bodyPr wrap="square" lIns="0" tIns="0" rIns="0" bIns="0" rtlCol="0" anchor="b"/>
-          <a:lstStyle/>
-          <a:p>
-            <a:pPr indent="0" marL="0">
-              <a:buNone/>
-            </a:pPr>
-            <a:r>
-              <a:rPr lang="en-US" sz="4600" dirty="0">
-                <a:solidFill>
-                  <a:schemeClr val="accent1"/>
-                </a:solidFill>
-                <a:latin typeface="Cambria" pitchFamily="34" charset="0"/>
-                <a:ea typeface="Cambria" pitchFamily="34" charset="-122"/>
-                <a:cs typeface="Cambria" pitchFamily="34" charset="-120"/>
-              </a:rPr>
-              <a:t>18.3 ms</a:t>
-            </a:r>
-            <a:endParaRPr lang="en-US" sz="4600" dirty="0"/>
-          </a:p>
-        </p:txBody>
-      </p:sp>
-      <p:sp>
-        <p:nvSpPr>
-          <p:cNvPr id="6" name="Text 4"/>
-          <p:cNvSpPr txBox="1"/>
-          <p:nvPr/>
-        </p:nvSpPr>
-        <p:spPr>
-          <a:xfrm>
-            <a:off x="685800" y="2587752"/>
-            <a:ext cx="3566160" cy="502920"/>
-          </a:xfrm>
-          <a:prstGeom prst="rect">
-            <a:avLst/>
-          </a:prstGeom>
-          <a:noFill/>
-          <a:ln/>
-        </p:spPr>
-        <p:txBody>
-          <a:bodyPr wrap="square" lIns="0" tIns="0" rIns="0" bIns="0" rtlCol="0" anchor="t"/>
-          <a:lstStyle/>
-          <a:p>
-            <a:pPr indent="0" marL="0">
-              <a:buNone/>
-            </a:pPr>
-            <a:r>
-              <a:rPr lang="en-US" sz="1400" dirty="0">
-                <a:solidFill>
-                  <a:schemeClr val="accent3"/>
-                </a:solidFill>
-                <a:latin typeface="Calibri" pitchFamily="34" charset="0"/>
-                <a:ea typeface="Calibri" pitchFamily="34" charset="-122"/>
-                <a:cs typeface="Calibri" pitchFamily="34" charset="-120"/>
-              </a:rPr>
-              <a:t>mean error per speech sound</a:t>
-            </a:r>
-            <a:endParaRPr lang="en-US" sz="1400" dirty="0"/>
           </a:p>
         </p:txBody>
       </p:sp>
@@ -7306,17 +7228,16 @@
           </p:nvPr>
         </p:nvGraphicFramePr>
         <p:xfrm>
-          <a:off x="685800" y="3063240"/>
-          <a:ext cx="3383280" cy="914400"/>
+          <a:off x="685800" y="1737360"/>
+          <a:ext cx="3657600" cy="914400"/>
         </p:xfrm>
         <a:graphic>
           <a:graphicData uri="http://schemas.openxmlformats.org/drawingml/2006/table">
             <a:tbl>
               <a:tblPr/>
               <a:tblGrid>
-                <a:gridCol w="1554480"/>
-                <a:gridCol w="914400"/>
-                <a:gridCol w="914400"/>
+                <a:gridCol w="2468880"/>
+                <a:gridCol w="1188720"/>
               </a:tblGrid>
               <a:tr h="292608">
                 <a:tc>
@@ -7336,7 +7257,7 @@
                           <a:ea typeface="Calibri" pitchFamily="34" charset="-122"/>
                           <a:cs typeface="Calibri" pitchFamily="34" charset="-120"/>
                         </a:rPr>
-                        <a:t>MAE</a:t>
+                        <a:t>MODEL</a:t>
                       </a:r>
                       <a:endParaRPr lang="en-US" sz="900" dirty="0">
                         <a:latin typeface="Calibri" charset="0"/>
@@ -7383,54 +7304,7 @@
                           <a:ea typeface="Calibri" pitchFamily="34" charset="-122"/>
                           <a:cs typeface="Calibri" pitchFamily="34" charset="-120"/>
                         </a:rPr>
-                        <a:t>SPEECH</a:t>
-                      </a:r>
-                      <a:endParaRPr lang="en-US" sz="900" dirty="0">
-                        <a:latin typeface="Calibri" charset="0"/>
-                        <a:ea typeface="Calibri" charset="0"/>
-                        <a:cs typeface="Calibri" charset="0"/>
-                      </a:endParaRPr>
-                    </a:p>
-                  </a:txBody>
-                  <a:tcPr marL="0" marR="50800" marT="25400" marB="25400" anchor="b">
-                    <a:lnL w="0" cap="flat" cmpd="sng" algn="ctr">
-                      <a:noFill/>
-                    </a:lnL>
-                    <a:lnR w="0" cap="flat" cmpd="sng" algn="ctr">
-                      <a:noFill/>
-                    </a:lnR>
-                    <a:lnT w="0" cap="flat" cmpd="sng" algn="ctr">
-                      <a:noFill/>
-                    </a:lnT>
-                    <a:lnB w="9525" cap="flat" cmpd="sng" algn="ctr">
-                      <a:solidFill>
-                        <a:srgbClr val="C9CDD3"/>
-                      </a:solidFill>
-                      <a:prstDash val="solid"/>
-                      <a:round/>
-                      <a:headEnd type="none" w="med" len="med"/>
-                      <a:tailEnd type="none" w="med" len="med"/>
-                    </a:lnB>
-                  </a:tcPr>
-                </a:tc>
-                <a:tc>
-                  <a:txBody>
-                    <a:bodyPr/>
-                    <a:lstStyle/>
-                    <a:p>
-                      <a:pPr indent="0" marL="0">
-                        <a:buNone/>
-                      </a:pPr>
-                      <a:r>
-                        <a:rPr lang="en-US" sz="900" spc="100" kern="0" dirty="0">
-                          <a:solidFill>
-                            <a:srgbClr val="7A7F87"/>
-                          </a:solidFill>
-                          <a:latin typeface="Calibri" pitchFamily="34" charset="0"/>
-                          <a:ea typeface="Calibri" pitchFamily="34" charset="-122"/>
-                          <a:cs typeface="Calibri" pitchFamily="34" charset="-120"/>
-                        </a:rPr>
-                        <a:t>PAUSES</a:t>
+                        <a:t>MAE</a:t>
                       </a:r>
                       <a:endParaRPr lang="en-US" sz="900" dirty="0">
                         <a:latin typeface="Calibri" charset="0"/>
@@ -7471,7 +7345,7 @@
                         <a:buNone/>
                       </a:pPr>
                       <a:r>
-                        <a:rPr lang="en-US" sz="1100" dirty="0">
+                        <a:rPr lang="en-US" sz="1200" dirty="0">
                           <a:solidFill>
                             <a:srgbClr val="222222"/>
                           </a:solidFill>
@@ -7481,7 +7355,7 @@
                         </a:rPr>
                         <a:t>Per-phoneme mean</a:t>
                       </a:r>
-                      <a:endParaRPr lang="en-US" sz="1100" dirty="0">
+                      <a:endParaRPr lang="en-US" sz="1200" dirty="0">
                         <a:latin typeface="Cambria" charset="0"/>
                         <a:ea typeface="Cambria" charset="0"/>
                         <a:cs typeface="Cambria" charset="0"/>
@@ -7518,7 +7392,7 @@
                         <a:buNone/>
                       </a:pPr>
                       <a:r>
-                        <a:rPr lang="en-US" sz="1100" dirty="0">
+                        <a:rPr lang="en-US" sz="1200" dirty="0">
                           <a:solidFill>
                             <a:srgbClr val="222222"/>
                           </a:solidFill>
@@ -7528,54 +7402,7 @@
                         </a:rPr>
                         <a:t>28.8 ms</a:t>
                       </a:r>
-                      <a:endParaRPr lang="en-US" sz="1100" dirty="0">
-                        <a:latin typeface="Calibri" charset="0"/>
-                        <a:ea typeface="Calibri" charset="0"/>
-                        <a:cs typeface="Calibri" charset="0"/>
-                      </a:endParaRPr>
-                    </a:p>
-                  </a:txBody>
-                  <a:tcPr marL="0" marR="50800" marT="25400" marB="25400">
-                    <a:lnL w="0" cap="flat" cmpd="sng" algn="ctr">
-                      <a:noFill/>
-                    </a:lnL>
-                    <a:lnR w="0" cap="flat" cmpd="sng" algn="ctr">
-                      <a:noFill/>
-                    </a:lnR>
-                    <a:lnT w="0" cap="flat" cmpd="sng" algn="ctr">
-                      <a:noFill/>
-                    </a:lnT>
-                    <a:lnB w="9525" cap="flat" cmpd="sng" algn="ctr">
-                      <a:solidFill>
-                        <a:srgbClr val="C9CDD3"/>
-                      </a:solidFill>
-                      <a:prstDash val="solid"/>
-                      <a:round/>
-                      <a:headEnd type="none" w="med" len="med"/>
-                      <a:tailEnd type="none" w="med" len="med"/>
-                    </a:lnB>
-                  </a:tcPr>
-                </a:tc>
-                <a:tc>
-                  <a:txBody>
-                    <a:bodyPr/>
-                    <a:lstStyle/>
-                    <a:p>
-                      <a:pPr indent="0" marL="0">
-                        <a:buNone/>
-                      </a:pPr>
-                      <a:r>
-                        <a:rPr lang="en-US" sz="1100" dirty="0">
-                          <a:solidFill>
-                            <a:srgbClr val="222222"/>
-                          </a:solidFill>
-                          <a:latin typeface="Calibri" pitchFamily="34" charset="0"/>
-                          <a:ea typeface="Calibri" pitchFamily="34" charset="-122"/>
-                          <a:cs typeface="Calibri" pitchFamily="34" charset="-120"/>
-                        </a:rPr>
-                        <a:t>145.6 ms</a:t>
-                      </a:r>
-                      <a:endParaRPr lang="en-US" sz="1100" dirty="0">
+                      <a:endParaRPr lang="en-US" sz="1200" dirty="0">
                         <a:latin typeface="Calibri" charset="0"/>
                         <a:ea typeface="Calibri" charset="0"/>
                         <a:cs typeface="Calibri" charset="0"/>
@@ -7614,17 +7441,17 @@
                         <a:buNone/>
                       </a:pPr>
                       <a:r>
-                        <a:rPr lang="en-US" sz="1100" dirty="0">
+                        <a:rPr lang="en-US" sz="1200" dirty="0">
                           <a:solidFill>
-                            <a:srgbClr val="1F3A5F"/>
+                            <a:srgbClr val="222222"/>
                           </a:solidFill>
                           <a:latin typeface="Cambria" pitchFamily="34" charset="0"/>
                           <a:ea typeface="Cambria" pitchFamily="34" charset="-122"/>
                           <a:cs typeface="Cambria" pitchFamily="34" charset="-120"/>
                         </a:rPr>
-                        <a:t>LightGBM</a:t>
+                        <a:t>Ridge (linear)</a:t>
                       </a:r>
-                      <a:endParaRPr lang="en-US" sz="1100" dirty="0">
+                      <a:endParaRPr lang="en-US" sz="1200" dirty="0">
                         <a:latin typeface="Cambria" charset="0"/>
                         <a:ea typeface="Cambria" charset="0"/>
                         <a:cs typeface="Cambria" charset="0"/>
@@ -7661,20 +7488,69 @@
                         <a:buNone/>
                       </a:pPr>
                       <a:r>
-                        <a:rPr lang="en-US" sz="1100" dirty="0">
+                        <a:rPr lang="en-US" sz="1200" dirty="0">
                           <a:solidFill>
-                            <a:srgbClr val="1F3A5F"/>
+                            <a:srgbClr val="222222"/>
                           </a:solidFill>
                           <a:latin typeface="Calibri" pitchFamily="34" charset="0"/>
                           <a:ea typeface="Calibri" pitchFamily="34" charset="-122"/>
                           <a:cs typeface="Calibri" pitchFamily="34" charset="-120"/>
                         </a:rPr>
-                        <a:t>18.3 ms</a:t>
+                        <a:t>25.1 ms</a:t>
                       </a:r>
-                      <a:endParaRPr lang="en-US" sz="1100" dirty="0">
+                      <a:endParaRPr lang="en-US" sz="1200" dirty="0">
                         <a:latin typeface="Calibri" charset="0"/>
                         <a:ea typeface="Calibri" charset="0"/>
                         <a:cs typeface="Calibri" charset="0"/>
+                      </a:endParaRPr>
+                    </a:p>
+                  </a:txBody>
+                  <a:tcPr marL="0" marR="50800" marT="25400" marB="25400">
+                    <a:lnL w="0" cap="flat" cmpd="sng" algn="ctr">
+                      <a:noFill/>
+                    </a:lnL>
+                    <a:lnR w="0" cap="flat" cmpd="sng" algn="ctr">
+                      <a:noFill/>
+                    </a:lnR>
+                    <a:lnT w="0" cap="flat" cmpd="sng" algn="ctr">
+                      <a:noFill/>
+                    </a:lnT>
+                    <a:lnB w="9525" cap="flat" cmpd="sng" algn="ctr">
+                      <a:solidFill>
+                        <a:srgbClr val="C9CDD3"/>
+                      </a:solidFill>
+                      <a:prstDash val="solid"/>
+                      <a:round/>
+                      <a:headEnd type="none" w="med" len="med"/>
+                      <a:tailEnd type="none" w="med" len="med"/>
+                    </a:lnB>
+                  </a:tcPr>
+                </a:tc>
+              </a:tr>
+              <a:tr h="292608">
+                <a:tc>
+                  <a:txBody>
+                    <a:bodyPr/>
+                    <a:lstStyle/>
+                    <a:p>
+                      <a:pPr indent="0" marL="0">
+                        <a:buNone/>
+                      </a:pPr>
+                      <a:r>
+                        <a:rPr lang="en-US" sz="1200" dirty="0">
+                          <a:solidFill>
+                            <a:srgbClr val="222222"/>
+                          </a:solidFill>
+                          <a:latin typeface="Cambria" pitchFamily="34" charset="0"/>
+                          <a:ea typeface="Cambria" pitchFamily="34" charset="-122"/>
+                          <a:cs typeface="Cambria" pitchFamily="34" charset="-120"/>
+                        </a:rPr>
+                        <a:t>MLP</a:t>
+                      </a:r>
+                      <a:endParaRPr lang="en-US" sz="1200" dirty="0">
+                        <a:latin typeface="Cambria" charset="0"/>
+                        <a:ea typeface="Cambria" charset="0"/>
+                        <a:cs typeface="Cambria" charset="0"/>
                       </a:endParaRPr>
                     </a:p>
                   </a:txBody>
@@ -7708,17 +7584,17 @@
                         <a:buNone/>
                       </a:pPr>
                       <a:r>
-                        <a:rPr lang="en-US" sz="1100" dirty="0">
+                        <a:rPr lang="en-US" sz="1200" dirty="0">
                           <a:solidFill>
-                            <a:srgbClr val="1F3A5F"/>
+                            <a:srgbClr val="222222"/>
                           </a:solidFill>
                           <a:latin typeface="Calibri" pitchFamily="34" charset="0"/>
                           <a:ea typeface="Calibri" pitchFamily="34" charset="-122"/>
                           <a:cs typeface="Calibri" pitchFamily="34" charset="-120"/>
                         </a:rPr>
-                        <a:t>112.9 ms</a:t>
+                        <a:t>19.3 ms</a:t>
                       </a:r>
-                      <a:endParaRPr lang="en-US" sz="1100" dirty="0">
+                      <a:endParaRPr lang="en-US" sz="1200" dirty="0">
                         <a:latin typeface="Calibri" charset="0"/>
                         <a:ea typeface="Calibri" charset="0"/>
                         <a:cs typeface="Calibri" charset="0"/>
@@ -7747,154 +7623,6 @@
                   </a:tcPr>
                 </a:tc>
               </a:tr>
-            </a:tbl>
-          </a:graphicData>
-        </a:graphic>
-      </p:graphicFrame>
-      <p:sp>
-        <p:nvSpPr>
-          <p:cNvPr id="8" name="Text 5"/>
-          <p:cNvSpPr txBox="1"/>
-          <p:nvPr/>
-        </p:nvSpPr>
-        <p:spPr>
-          <a:xfrm>
-            <a:off x="4754880" y="1463040"/>
-            <a:ext cx="3566160" cy="228600"/>
-          </a:xfrm>
-          <a:prstGeom prst="rect">
-            <a:avLst/>
-          </a:prstGeom>
-          <a:noFill/>
-          <a:ln/>
-        </p:spPr>
-        <p:txBody>
-          <a:bodyPr wrap="square" lIns="0" tIns="0" rIns="0" bIns="0" rtlCol="0" anchor="ctr"/>
-          <a:lstStyle/>
-          <a:p>
-            <a:pPr indent="0" marL="0">
-              <a:buNone/>
-            </a:pPr>
-            <a:r>
-              <a:rPr lang="en-US" sz="900" spc="300" kern="0" dirty="0">
-                <a:solidFill>
-                  <a:schemeClr val="accent3"/>
-                </a:solidFill>
-                <a:latin typeface="Calibri" pitchFamily="34" charset="0"/>
-                <a:ea typeface="Calibri" pitchFamily="34" charset="-122"/>
-                <a:cs typeface="Calibri" pitchFamily="34" charset="-120"/>
-              </a:rPr>
-              <a:t>PAUSES</a:t>
-            </a:r>
-            <a:endParaRPr lang="en-US" sz="900" dirty="0"/>
-          </a:p>
-        </p:txBody>
-      </p:sp>
-      <p:sp>
-        <p:nvSpPr>
-          <p:cNvPr id="9" name="Text 6"/>
-          <p:cNvSpPr txBox="1"/>
-          <p:nvPr/>
-        </p:nvSpPr>
-        <p:spPr>
-          <a:xfrm>
-            <a:off x="4754880" y="1600200"/>
-            <a:ext cx="3566160" cy="914400"/>
-          </a:xfrm>
-          <a:prstGeom prst="rect">
-            <a:avLst/>
-          </a:prstGeom>
-          <a:noFill/>
-          <a:ln/>
-        </p:spPr>
-        <p:txBody>
-          <a:bodyPr wrap="square" lIns="0" tIns="0" rIns="0" bIns="0" rtlCol="0" anchor="b"/>
-          <a:lstStyle/>
-          <a:p>
-            <a:pPr indent="0" marL="0">
-              <a:buNone/>
-            </a:pPr>
-            <a:r>
-              <a:rPr lang="en-US" sz="4600" dirty="0">
-                <a:solidFill>
-                  <a:schemeClr val="accent1"/>
-                </a:solidFill>
-                <a:latin typeface="Cambria" pitchFamily="34" charset="0"/>
-                <a:ea typeface="Cambria" pitchFamily="34" charset="-122"/>
-                <a:cs typeface="Cambria" pitchFamily="34" charset="-120"/>
-              </a:rPr>
-              <a:t>64.2%</a:t>
-            </a:r>
-            <a:endParaRPr lang="en-US" sz="4600" dirty="0"/>
-          </a:p>
-        </p:txBody>
-      </p:sp>
-      <p:sp>
-        <p:nvSpPr>
-          <p:cNvPr id="10" name="Text 7"/>
-          <p:cNvSpPr txBox="1"/>
-          <p:nvPr/>
-        </p:nvSpPr>
-        <p:spPr>
-          <a:xfrm>
-            <a:off x="4754880" y="2587752"/>
-            <a:ext cx="3566160" cy="502920"/>
-          </a:xfrm>
-          <a:prstGeom prst="rect">
-            <a:avLst/>
-          </a:prstGeom>
-          <a:noFill/>
-          <a:ln/>
-        </p:spPr>
-        <p:txBody>
-          <a:bodyPr wrap="square" lIns="0" tIns="0" rIns="0" bIns="0" rtlCol="0" anchor="t"/>
-          <a:lstStyle/>
-          <a:p>
-            <a:pPr indent="0" marL="0">
-              <a:buNone/>
-            </a:pPr>
-            <a:r>
-              <a:rPr lang="en-US" sz="1400" dirty="0">
-                <a:solidFill>
-                  <a:schemeClr val="accent3"/>
-                </a:solidFill>
-                <a:latin typeface="Calibri" pitchFamily="34" charset="0"/>
-                <a:ea typeface="Calibri" pitchFamily="34" charset="-122"/>
-                <a:cs typeface="Calibri" pitchFamily="34" charset="-120"/>
-              </a:rPr>
-              <a:t>F1 for pause placement</a:t>
-            </a:r>
-            <a:endParaRPr lang="en-US" sz="1400" dirty="0"/>
-          </a:p>
-        </p:txBody>
-      </p:sp>
-      <p:graphicFrame>
-        <p:nvGraphicFramePr>
-          <p:cNvPr id="11" name="Table 1"/>
-          <p:cNvGraphicFramePr>
-            <a:graphicFrameLocks noGrp="1"/>
-          </p:cNvGraphicFramePr>
-          <p:nvPr>
-            <p:extLst>
-              <p:ext uri="{D42A27DB-BD31-4B8C-83A1-F6EECF244321}">
-                <p14:modId xmlns:p14="http://schemas.microsoft.com/office/powerpoint/2010/main" val="1579011935"/>
-              </p:ext>
-            </p:extLst>
-          </p:nvPr>
-        </p:nvGraphicFramePr>
-        <p:xfrm>
-          <a:off x="4754880" y="3063240"/>
-          <a:ext cx="3383280" cy="914400"/>
-        </p:xfrm>
-        <a:graphic>
-          <a:graphicData uri="http://schemas.openxmlformats.org/drawingml/2006/table">
-            <a:tbl>
-              <a:tblPr/>
-              <a:tblGrid>
-                <a:gridCol w="1554480"/>
-                <a:gridCol w="914400"/>
-                <a:gridCol w="914400"/>
-              </a:tblGrid>
               <a:tr h="292608">
                 <a:tc>
                   <a:txBody>
@@ -7905,24 +7633,24 @@
                         <a:buNone/>
                       </a:pPr>
                       <a:r>
-                        <a:rPr lang="en-US" sz="900" spc="100" kern="0" dirty="0">
+                        <a:rPr lang="en-US" sz="1200" dirty="0">
                           <a:solidFill>
-                            <a:srgbClr val="7A7F87"/>
+                            <a:srgbClr val="222222"/>
                           </a:solidFill>
-                          <a:latin typeface="Calibri" pitchFamily="34" charset="0"/>
-                          <a:ea typeface="Calibri" pitchFamily="34" charset="-122"/>
-                          <a:cs typeface="Calibri" pitchFamily="34" charset="-120"/>
+                          <a:latin typeface="Cambria" pitchFamily="34" charset="0"/>
+                          <a:ea typeface="Cambria" pitchFamily="34" charset="-122"/>
+                          <a:cs typeface="Cambria" pitchFamily="34" charset="-120"/>
                         </a:rPr>
-                        <a:t>PAUSES</a:t>
+                        <a:t>Random forest</a:t>
                       </a:r>
-                      <a:endParaRPr lang="en-US" sz="900" dirty="0">
-                        <a:latin typeface="Calibri" charset="0"/>
-                        <a:ea typeface="Calibri" charset="0"/>
-                        <a:cs typeface="Calibri" charset="0"/>
+                      <a:endParaRPr lang="en-US" sz="1200" dirty="0">
+                        <a:latin typeface="Cambria" charset="0"/>
+                        <a:ea typeface="Cambria" charset="0"/>
+                        <a:cs typeface="Cambria" charset="0"/>
                       </a:endParaRPr>
                     </a:p>
                   </a:txBody>
-                  <a:tcPr marL="0" marR="50800" marT="25400" marB="25400" anchor="b">
+                  <a:tcPr marL="0" marR="50800" marT="25400" marB="25400">
                     <a:lnL w="0" cap="flat" cmpd="sng" algn="ctr">
                       <a:noFill/>
                     </a:lnL>
@@ -7952,6 +7680,220 @@
                         <a:buNone/>
                       </a:pPr>
                       <a:r>
+                        <a:rPr lang="en-US" sz="1200" dirty="0">
+                          <a:solidFill>
+                            <a:srgbClr val="222222"/>
+                          </a:solidFill>
+                          <a:latin typeface="Calibri" pitchFamily="34" charset="0"/>
+                          <a:ea typeface="Calibri" pitchFamily="34" charset="-122"/>
+                          <a:cs typeface="Calibri" pitchFamily="34" charset="-120"/>
+                        </a:rPr>
+                        <a:t>18.8 ms</a:t>
+                      </a:r>
+                      <a:endParaRPr lang="en-US" sz="1200" dirty="0">
+                        <a:latin typeface="Calibri" charset="0"/>
+                        <a:ea typeface="Calibri" charset="0"/>
+                        <a:cs typeface="Calibri" charset="0"/>
+                      </a:endParaRPr>
+                    </a:p>
+                  </a:txBody>
+                  <a:tcPr marL="0" marR="50800" marT="25400" marB="25400">
+                    <a:lnL w="0" cap="flat" cmpd="sng" algn="ctr">
+                      <a:noFill/>
+                    </a:lnL>
+                    <a:lnR w="0" cap="flat" cmpd="sng" algn="ctr">
+                      <a:noFill/>
+                    </a:lnR>
+                    <a:lnT w="0" cap="flat" cmpd="sng" algn="ctr">
+                      <a:noFill/>
+                    </a:lnT>
+                    <a:lnB w="9525" cap="flat" cmpd="sng" algn="ctr">
+                      <a:solidFill>
+                        <a:srgbClr val="C9CDD3"/>
+                      </a:solidFill>
+                      <a:prstDash val="solid"/>
+                      <a:round/>
+                      <a:headEnd type="none" w="med" len="med"/>
+                      <a:tailEnd type="none" w="med" len="med"/>
+                    </a:lnB>
+                  </a:tcPr>
+                </a:tc>
+              </a:tr>
+              <a:tr h="292608">
+                <a:tc>
+                  <a:txBody>
+                    <a:bodyPr/>
+                    <a:lstStyle/>
+                    <a:p>
+                      <a:pPr indent="0" marL="0">
+                        <a:buNone/>
+                      </a:pPr>
+                      <a:r>
+                        <a:rPr lang="en-US" sz="1200" dirty="0">
+                          <a:solidFill>
+                            <a:srgbClr val="1F3A5F"/>
+                          </a:solidFill>
+                          <a:latin typeface="Cambria" pitchFamily="34" charset="0"/>
+                          <a:ea typeface="Cambria" pitchFamily="34" charset="-122"/>
+                          <a:cs typeface="Cambria" pitchFamily="34" charset="-120"/>
+                        </a:rPr>
+                        <a:t>LightGBM</a:t>
+                      </a:r>
+                      <a:endParaRPr lang="en-US" sz="1200" dirty="0">
+                        <a:latin typeface="Cambria" charset="0"/>
+                        <a:ea typeface="Cambria" charset="0"/>
+                        <a:cs typeface="Cambria" charset="0"/>
+                      </a:endParaRPr>
+                    </a:p>
+                  </a:txBody>
+                  <a:tcPr marL="0" marR="50800" marT="25400" marB="25400">
+                    <a:lnL w="0" cap="flat" cmpd="sng" algn="ctr">
+                      <a:noFill/>
+                    </a:lnL>
+                    <a:lnR w="0" cap="flat" cmpd="sng" algn="ctr">
+                      <a:noFill/>
+                    </a:lnR>
+                    <a:lnT w="0" cap="flat" cmpd="sng" algn="ctr">
+                      <a:noFill/>
+                    </a:lnT>
+                    <a:lnB w="9525" cap="flat" cmpd="sng" algn="ctr">
+                      <a:solidFill>
+                        <a:srgbClr val="C9CDD3"/>
+                      </a:solidFill>
+                      <a:prstDash val="solid"/>
+                      <a:round/>
+                      <a:headEnd type="none" w="med" len="med"/>
+                      <a:tailEnd type="none" w="med" len="med"/>
+                    </a:lnB>
+                  </a:tcPr>
+                </a:tc>
+                <a:tc>
+                  <a:txBody>
+                    <a:bodyPr/>
+                    <a:lstStyle/>
+                    <a:p>
+                      <a:pPr indent="0" marL="0">
+                        <a:buNone/>
+                      </a:pPr>
+                      <a:r>
+                        <a:rPr lang="en-US" sz="1200" dirty="0">
+                          <a:solidFill>
+                            <a:srgbClr val="1F3A5F"/>
+                          </a:solidFill>
+                          <a:latin typeface="Calibri" pitchFamily="34" charset="0"/>
+                          <a:ea typeface="Calibri" pitchFamily="34" charset="-122"/>
+                          <a:cs typeface="Calibri" pitchFamily="34" charset="-120"/>
+                        </a:rPr>
+                        <a:t>18.3 ms</a:t>
+                      </a:r>
+                      <a:endParaRPr lang="en-US" sz="1200" dirty="0">
+                        <a:latin typeface="Calibri" charset="0"/>
+                        <a:ea typeface="Calibri" charset="0"/>
+                        <a:cs typeface="Calibri" charset="0"/>
+                      </a:endParaRPr>
+                    </a:p>
+                  </a:txBody>
+                  <a:tcPr marL="0" marR="50800" marT="25400" marB="25400">
+                    <a:lnL w="0" cap="flat" cmpd="sng" algn="ctr">
+                      <a:noFill/>
+                    </a:lnL>
+                    <a:lnR w="0" cap="flat" cmpd="sng" algn="ctr">
+                      <a:noFill/>
+                    </a:lnR>
+                    <a:lnT w="0" cap="flat" cmpd="sng" algn="ctr">
+                      <a:noFill/>
+                    </a:lnT>
+                    <a:lnB w="9525" cap="flat" cmpd="sng" algn="ctr">
+                      <a:solidFill>
+                        <a:srgbClr val="C9CDD3"/>
+                      </a:solidFill>
+                      <a:prstDash val="solid"/>
+                      <a:round/>
+                      <a:headEnd type="none" w="med" len="med"/>
+                      <a:tailEnd type="none" w="med" len="med"/>
+                    </a:lnB>
+                  </a:tcPr>
+                </a:tc>
+              </a:tr>
+            </a:tbl>
+          </a:graphicData>
+        </a:graphic>
+      </p:graphicFrame>
+      <p:sp>
+        <p:nvSpPr>
+          <p:cNvPr id="6" name="Text 3"/>
+          <p:cNvSpPr txBox="1"/>
+          <p:nvPr/>
+        </p:nvSpPr>
+        <p:spPr>
+          <a:xfrm>
+            <a:off x="4754880" y="1463040"/>
+            <a:ext cx="3749040" cy="228600"/>
+          </a:xfrm>
+          <a:prstGeom prst="rect">
+            <a:avLst/>
+          </a:prstGeom>
+          <a:noFill/>
+          <a:ln/>
+        </p:spPr>
+        <p:txBody>
+          <a:bodyPr wrap="square" lIns="0" tIns="0" rIns="0" bIns="0" rtlCol="0" anchor="ctr"/>
+          <a:lstStyle/>
+          <a:p>
+            <a:pPr indent="0" marL="0">
+              <a:buNone/>
+            </a:pPr>
+            <a:r>
+              <a:rPr lang="en-US" sz="900" spc="300" kern="0" dirty="0">
+                <a:solidFill>
+                  <a:schemeClr val="accent3"/>
+                </a:solidFill>
+                <a:latin typeface="Calibri" pitchFamily="34" charset="0"/>
+                <a:ea typeface="Calibri" pitchFamily="34" charset="-122"/>
+                <a:cs typeface="Calibri" pitchFamily="34" charset="-120"/>
+              </a:rPr>
+              <a:t>PAUSE PLACEMENT  ·  F1</a:t>
+            </a:r>
+            <a:endParaRPr lang="en-US" sz="900" dirty="0"/>
+          </a:p>
+        </p:txBody>
+      </p:sp>
+      <p:graphicFrame>
+        <p:nvGraphicFramePr>
+          <p:cNvPr id="11" name="Table 1"/>
+          <p:cNvGraphicFramePr>
+            <a:graphicFrameLocks noGrp="1"/>
+          </p:cNvGraphicFramePr>
+          <p:nvPr>
+            <p:extLst>
+              <p:ext uri="{D42A27DB-BD31-4B8C-83A1-F6EECF244321}">
+                <p14:modId xmlns:p14="http://schemas.microsoft.com/office/powerpoint/2010/main" val="1579011935"/>
+              </p:ext>
+            </p:extLst>
+          </p:nvPr>
+        </p:nvGraphicFramePr>
+        <p:xfrm>
+          <a:off x="4754880" y="1737360"/>
+          <a:ext cx="3703320" cy="914400"/>
+        </p:xfrm>
+        <a:graphic>
+          <a:graphicData uri="http://schemas.openxmlformats.org/drawingml/2006/table">
+            <a:tbl>
+              <a:tblPr/>
+              <a:tblGrid>
+                <a:gridCol w="2514600"/>
+                <a:gridCol w="1188720"/>
+              </a:tblGrid>
+              <a:tr h="292608">
+                <a:tc>
+                  <a:txBody>
+                    <a:bodyPr/>
+                    <a:lstStyle/>
+                    <a:p>
+                      <a:pPr indent="0" marL="0">
+                        <a:buNone/>
+                      </a:pPr>
+                      <a:r>
                         <a:rPr lang="en-US" sz="900" spc="100" kern="0" dirty="0">
                           <a:solidFill>
                             <a:srgbClr val="7A7F87"/>
@@ -7960,7 +7902,7 @@
                           <a:ea typeface="Calibri" pitchFamily="34" charset="-122"/>
                           <a:cs typeface="Calibri" pitchFamily="34" charset="-120"/>
                         </a:rPr>
-                        <a:t>RECALL</a:t>
+                        <a:t>MODEL</a:t>
                       </a:r>
                       <a:endParaRPr lang="en-US" sz="900" dirty="0">
                         <a:latin typeface="Calibri" charset="0"/>
@@ -8048,7 +7990,7 @@
                         <a:buNone/>
                       </a:pPr>
                       <a:r>
-                        <a:rPr lang="en-US" sz="1100" dirty="0">
+                        <a:rPr lang="en-US" sz="1200" dirty="0">
                           <a:solidFill>
                             <a:srgbClr val="222222"/>
                           </a:solidFill>
@@ -8058,7 +8000,7 @@
                         </a:rPr>
                         <a:t>Punctuation rule</a:t>
                       </a:r>
-                      <a:endParaRPr lang="en-US" sz="1100" dirty="0">
+                      <a:endParaRPr lang="en-US" sz="1200" dirty="0">
                         <a:latin typeface="Cambria" charset="0"/>
                         <a:ea typeface="Cambria" charset="0"/>
                         <a:cs typeface="Cambria" charset="0"/>
@@ -8095,54 +8037,7 @@
                         <a:buNone/>
                       </a:pPr>
                       <a:r>
-                        <a:rPr lang="en-US" sz="1100" dirty="0">
-                          <a:solidFill>
-                            <a:srgbClr val="222222"/>
-                          </a:solidFill>
-                          <a:latin typeface="Calibri" pitchFamily="34" charset="0"/>
-                          <a:ea typeface="Calibri" pitchFamily="34" charset="-122"/>
-                          <a:cs typeface="Calibri" pitchFamily="34" charset="-120"/>
-                        </a:rPr>
-                        <a:t>51.5%</a:t>
-                      </a:r>
-                      <a:endParaRPr lang="en-US" sz="1100" dirty="0">
-                        <a:latin typeface="Calibri" charset="0"/>
-                        <a:ea typeface="Calibri" charset="0"/>
-                        <a:cs typeface="Calibri" charset="0"/>
-                      </a:endParaRPr>
-                    </a:p>
-                  </a:txBody>
-                  <a:tcPr marL="0" marR="50800" marT="25400" marB="25400">
-                    <a:lnL w="0" cap="flat" cmpd="sng" algn="ctr">
-                      <a:noFill/>
-                    </a:lnL>
-                    <a:lnR w="0" cap="flat" cmpd="sng" algn="ctr">
-                      <a:noFill/>
-                    </a:lnR>
-                    <a:lnT w="0" cap="flat" cmpd="sng" algn="ctr">
-                      <a:noFill/>
-                    </a:lnT>
-                    <a:lnB w="9525" cap="flat" cmpd="sng" algn="ctr">
-                      <a:solidFill>
-                        <a:srgbClr val="C9CDD3"/>
-                      </a:solidFill>
-                      <a:prstDash val="solid"/>
-                      <a:round/>
-                      <a:headEnd type="none" w="med" len="med"/>
-                      <a:tailEnd type="none" w="med" len="med"/>
-                    </a:lnB>
-                  </a:tcPr>
-                </a:tc>
-                <a:tc>
-                  <a:txBody>
-                    <a:bodyPr/>
-                    <a:lstStyle/>
-                    <a:p>
-                      <a:pPr indent="0" marL="0">
-                        <a:buNone/>
-                      </a:pPr>
-                      <a:r>
-                        <a:rPr lang="en-US" sz="1100" dirty="0">
+                        <a:rPr lang="en-US" sz="1200" dirty="0">
                           <a:solidFill>
                             <a:srgbClr val="222222"/>
                           </a:solidFill>
@@ -8152,7 +8047,7 @@
                         </a:rPr>
                         <a:t>58.7%</a:t>
                       </a:r>
-                      <a:endParaRPr lang="en-US" sz="1100" dirty="0">
+                      <a:endParaRPr lang="en-US" sz="1200" dirty="0">
                         <a:latin typeface="Calibri" charset="0"/>
                         <a:ea typeface="Calibri" charset="0"/>
                         <a:cs typeface="Calibri" charset="0"/>
@@ -8191,17 +8086,17 @@
                         <a:buNone/>
                       </a:pPr>
                       <a:r>
-                        <a:rPr lang="en-US" sz="1100" dirty="0">
+                        <a:rPr lang="en-US" sz="1200" dirty="0">
                           <a:solidFill>
-                            <a:srgbClr val="1F3A5F"/>
+                            <a:srgbClr val="222222"/>
                           </a:solidFill>
                           <a:latin typeface="Cambria" pitchFamily="34" charset="0"/>
                           <a:ea typeface="Cambria" pitchFamily="34" charset="-122"/>
                           <a:cs typeface="Cambria" pitchFamily="34" charset="-120"/>
                         </a:rPr>
-                        <a:t>LightGBM</a:t>
+                        <a:t>Logistic regression</a:t>
                       </a:r>
-                      <a:endParaRPr lang="en-US" sz="1100" dirty="0">
+                      <a:endParaRPr lang="en-US" sz="1200" dirty="0">
                         <a:latin typeface="Cambria" charset="0"/>
                         <a:ea typeface="Cambria" charset="0"/>
                         <a:cs typeface="Cambria" charset="0"/>
@@ -8238,20 +8133,69 @@
                         <a:buNone/>
                       </a:pPr>
                       <a:r>
-                        <a:rPr lang="en-US" sz="1100" dirty="0">
+                        <a:rPr lang="en-US" sz="1200" dirty="0">
                           <a:solidFill>
-                            <a:srgbClr val="1F3A5F"/>
+                            <a:srgbClr val="222222"/>
                           </a:solidFill>
                           <a:latin typeface="Calibri" pitchFamily="34" charset="0"/>
                           <a:ea typeface="Calibri" pitchFamily="34" charset="-122"/>
                           <a:cs typeface="Calibri" pitchFamily="34" charset="-120"/>
                         </a:rPr>
-                        <a:t>60.6%</a:t>
+                        <a:t>61.1%</a:t>
                       </a:r>
-                      <a:endParaRPr lang="en-US" sz="1100" dirty="0">
+                      <a:endParaRPr lang="en-US" sz="1200" dirty="0">
                         <a:latin typeface="Calibri" charset="0"/>
                         <a:ea typeface="Calibri" charset="0"/>
                         <a:cs typeface="Calibri" charset="0"/>
+                      </a:endParaRPr>
+                    </a:p>
+                  </a:txBody>
+                  <a:tcPr marL="0" marR="50800" marT="25400" marB="25400">
+                    <a:lnL w="0" cap="flat" cmpd="sng" algn="ctr">
+                      <a:noFill/>
+                    </a:lnL>
+                    <a:lnR w="0" cap="flat" cmpd="sng" algn="ctr">
+                      <a:noFill/>
+                    </a:lnR>
+                    <a:lnT w="0" cap="flat" cmpd="sng" algn="ctr">
+                      <a:noFill/>
+                    </a:lnT>
+                    <a:lnB w="9525" cap="flat" cmpd="sng" algn="ctr">
+                      <a:solidFill>
+                        <a:srgbClr val="C9CDD3"/>
+                      </a:solidFill>
+                      <a:prstDash val="solid"/>
+                      <a:round/>
+                      <a:headEnd type="none" w="med" len="med"/>
+                      <a:tailEnd type="none" w="med" len="med"/>
+                    </a:lnB>
+                  </a:tcPr>
+                </a:tc>
+              </a:tr>
+              <a:tr h="292608">
+                <a:tc>
+                  <a:txBody>
+                    <a:bodyPr/>
+                    <a:lstStyle/>
+                    <a:p>
+                      <a:pPr indent="0" marL="0">
+                        <a:buNone/>
+                      </a:pPr>
+                      <a:r>
+                        <a:rPr lang="en-US" sz="1200" dirty="0">
+                          <a:solidFill>
+                            <a:srgbClr val="222222"/>
+                          </a:solidFill>
+                          <a:latin typeface="Cambria" pitchFamily="34" charset="0"/>
+                          <a:ea typeface="Cambria" pitchFamily="34" charset="-122"/>
+                          <a:cs typeface="Cambria" pitchFamily="34" charset="-120"/>
+                        </a:rPr>
+                        <a:t>Random forest</a:t>
+                      </a:r>
+                      <a:endParaRPr lang="en-US" sz="1200" dirty="0">
+                        <a:latin typeface="Cambria" charset="0"/>
+                        <a:ea typeface="Cambria" charset="0"/>
+                        <a:cs typeface="Cambria" charset="0"/>
                       </a:endParaRPr>
                     </a:p>
                   </a:txBody>
@@ -8285,7 +8229,199 @@
                         <a:buNone/>
                       </a:pPr>
                       <a:r>
-                        <a:rPr lang="en-US" sz="1100" dirty="0">
+                        <a:rPr lang="en-US" sz="1200" dirty="0">
+                          <a:solidFill>
+                            <a:srgbClr val="222222"/>
+                          </a:solidFill>
+                          <a:latin typeface="Calibri" pitchFamily="34" charset="0"/>
+                          <a:ea typeface="Calibri" pitchFamily="34" charset="-122"/>
+                          <a:cs typeface="Calibri" pitchFamily="34" charset="-120"/>
+                        </a:rPr>
+                        <a:t>63.0%</a:t>
+                      </a:r>
+                      <a:endParaRPr lang="en-US" sz="1200" dirty="0">
+                        <a:latin typeface="Calibri" charset="0"/>
+                        <a:ea typeface="Calibri" charset="0"/>
+                        <a:cs typeface="Calibri" charset="0"/>
+                      </a:endParaRPr>
+                    </a:p>
+                  </a:txBody>
+                  <a:tcPr marL="0" marR="50800" marT="25400" marB="25400">
+                    <a:lnL w="0" cap="flat" cmpd="sng" algn="ctr">
+                      <a:noFill/>
+                    </a:lnL>
+                    <a:lnR w="0" cap="flat" cmpd="sng" algn="ctr">
+                      <a:noFill/>
+                    </a:lnR>
+                    <a:lnT w="0" cap="flat" cmpd="sng" algn="ctr">
+                      <a:noFill/>
+                    </a:lnT>
+                    <a:lnB w="9525" cap="flat" cmpd="sng" algn="ctr">
+                      <a:solidFill>
+                        <a:srgbClr val="C9CDD3"/>
+                      </a:solidFill>
+                      <a:prstDash val="solid"/>
+                      <a:round/>
+                      <a:headEnd type="none" w="med" len="med"/>
+                      <a:tailEnd type="none" w="med" len="med"/>
+                    </a:lnB>
+                  </a:tcPr>
+                </a:tc>
+              </a:tr>
+              <a:tr h="292608">
+                <a:tc>
+                  <a:txBody>
+                    <a:bodyPr/>
+                    <a:lstStyle/>
+                    <a:p>
+                      <a:pPr indent="0" marL="0">
+                        <a:buNone/>
+                      </a:pPr>
+                      <a:r>
+                        <a:rPr lang="en-US" sz="1200" dirty="0">
+                          <a:solidFill>
+                            <a:srgbClr val="222222"/>
+                          </a:solidFill>
+                          <a:latin typeface="Cambria" pitchFamily="34" charset="0"/>
+                          <a:ea typeface="Cambria" pitchFamily="34" charset="-122"/>
+                          <a:cs typeface="Cambria" pitchFamily="34" charset="-120"/>
+                        </a:rPr>
+                        <a:t>MLP</a:t>
+                      </a:r>
+                      <a:endParaRPr lang="en-US" sz="1200" dirty="0">
+                        <a:latin typeface="Cambria" charset="0"/>
+                        <a:ea typeface="Cambria" charset="0"/>
+                        <a:cs typeface="Cambria" charset="0"/>
+                      </a:endParaRPr>
+                    </a:p>
+                  </a:txBody>
+                  <a:tcPr marL="0" marR="50800" marT="25400" marB="25400">
+                    <a:lnL w="0" cap="flat" cmpd="sng" algn="ctr">
+                      <a:noFill/>
+                    </a:lnL>
+                    <a:lnR w="0" cap="flat" cmpd="sng" algn="ctr">
+                      <a:noFill/>
+                    </a:lnR>
+                    <a:lnT w="0" cap="flat" cmpd="sng" algn="ctr">
+                      <a:noFill/>
+                    </a:lnT>
+                    <a:lnB w="9525" cap="flat" cmpd="sng" algn="ctr">
+                      <a:solidFill>
+                        <a:srgbClr val="C9CDD3"/>
+                      </a:solidFill>
+                      <a:prstDash val="solid"/>
+                      <a:round/>
+                      <a:headEnd type="none" w="med" len="med"/>
+                      <a:tailEnd type="none" w="med" len="med"/>
+                    </a:lnB>
+                  </a:tcPr>
+                </a:tc>
+                <a:tc>
+                  <a:txBody>
+                    <a:bodyPr/>
+                    <a:lstStyle/>
+                    <a:p>
+                      <a:pPr indent="0" marL="0">
+                        <a:buNone/>
+                      </a:pPr>
+                      <a:r>
+                        <a:rPr lang="en-US" sz="1200" dirty="0">
+                          <a:solidFill>
+                            <a:srgbClr val="222222"/>
+                          </a:solidFill>
+                          <a:latin typeface="Calibri" pitchFamily="34" charset="0"/>
+                          <a:ea typeface="Calibri" pitchFamily="34" charset="-122"/>
+                          <a:cs typeface="Calibri" pitchFamily="34" charset="-120"/>
+                        </a:rPr>
+                        <a:t>63.5%</a:t>
+                      </a:r>
+                      <a:endParaRPr lang="en-US" sz="1200" dirty="0">
+                        <a:latin typeface="Calibri" charset="0"/>
+                        <a:ea typeface="Calibri" charset="0"/>
+                        <a:cs typeface="Calibri" charset="0"/>
+                      </a:endParaRPr>
+                    </a:p>
+                  </a:txBody>
+                  <a:tcPr marL="0" marR="50800" marT="25400" marB="25400">
+                    <a:lnL w="0" cap="flat" cmpd="sng" algn="ctr">
+                      <a:noFill/>
+                    </a:lnL>
+                    <a:lnR w="0" cap="flat" cmpd="sng" algn="ctr">
+                      <a:noFill/>
+                    </a:lnR>
+                    <a:lnT w="0" cap="flat" cmpd="sng" algn="ctr">
+                      <a:noFill/>
+                    </a:lnT>
+                    <a:lnB w="9525" cap="flat" cmpd="sng" algn="ctr">
+                      <a:solidFill>
+                        <a:srgbClr val="C9CDD3"/>
+                      </a:solidFill>
+                      <a:prstDash val="solid"/>
+                      <a:round/>
+                      <a:headEnd type="none" w="med" len="med"/>
+                      <a:tailEnd type="none" w="med" len="med"/>
+                    </a:lnB>
+                  </a:tcPr>
+                </a:tc>
+              </a:tr>
+              <a:tr h="292608">
+                <a:tc>
+                  <a:txBody>
+                    <a:bodyPr/>
+                    <a:lstStyle/>
+                    <a:p>
+                      <a:pPr indent="0" marL="0">
+                        <a:buNone/>
+                      </a:pPr>
+                      <a:r>
+                        <a:rPr lang="en-US" sz="1200" dirty="0">
+                          <a:solidFill>
+                            <a:srgbClr val="1F3A5F"/>
+                          </a:solidFill>
+                          <a:latin typeface="Cambria" pitchFamily="34" charset="0"/>
+                          <a:ea typeface="Cambria" pitchFamily="34" charset="-122"/>
+                          <a:cs typeface="Cambria" pitchFamily="34" charset="-120"/>
+                        </a:rPr>
+                        <a:t>LightGBM</a:t>
+                      </a:r>
+                      <a:endParaRPr lang="en-US" sz="1200" dirty="0">
+                        <a:latin typeface="Cambria" charset="0"/>
+                        <a:ea typeface="Cambria" charset="0"/>
+                        <a:cs typeface="Cambria" charset="0"/>
+                      </a:endParaRPr>
+                    </a:p>
+                  </a:txBody>
+                  <a:tcPr marL="0" marR="50800" marT="25400" marB="25400">
+                    <a:lnL w="0" cap="flat" cmpd="sng" algn="ctr">
+                      <a:noFill/>
+                    </a:lnL>
+                    <a:lnR w="0" cap="flat" cmpd="sng" algn="ctr">
+                      <a:noFill/>
+                    </a:lnR>
+                    <a:lnT w="0" cap="flat" cmpd="sng" algn="ctr">
+                      <a:noFill/>
+                    </a:lnT>
+                    <a:lnB w="9525" cap="flat" cmpd="sng" algn="ctr">
+                      <a:solidFill>
+                        <a:srgbClr val="C9CDD3"/>
+                      </a:solidFill>
+                      <a:prstDash val="solid"/>
+                      <a:round/>
+                      <a:headEnd type="none" w="med" len="med"/>
+                      <a:tailEnd type="none" w="med" len="med"/>
+                    </a:lnB>
+                  </a:tcPr>
+                </a:tc>
+                <a:tc>
+                  <a:txBody>
+                    <a:bodyPr/>
+                    <a:lstStyle/>
+                    <a:p>
+                      <a:pPr indent="0" marL="0">
+                        <a:buNone/>
+                      </a:pPr>
+                      <a:r>
+                        <a:rPr lang="en-US" sz="1200" dirty="0">
                           <a:solidFill>
                             <a:srgbClr val="1F3A5F"/>
                           </a:solidFill>
@@ -8295,7 +8431,7 @@
                         </a:rPr>
                         <a:t>64.2%</a:t>
                       </a:r>
-                      <a:endParaRPr lang="en-US" sz="1100" dirty="0">
+                      <a:endParaRPr lang="en-US" sz="1200" dirty="0">
                         <a:latin typeface="Calibri" charset="0"/>
                         <a:ea typeface="Calibri" charset="0"/>
                         <a:cs typeface="Calibri" charset="0"/>
@@ -8330,13 +8466,13 @@
       </p:graphicFrame>
       <p:sp>
         <p:nvSpPr>
-          <p:cNvPr id="12" name="Text 8"/>
+          <p:cNvPr id="8" name="Text 4"/>
           <p:cNvSpPr txBox="1"/>
           <p:nvPr/>
         </p:nvSpPr>
         <p:spPr>
           <a:xfrm>
-            <a:off x="685800" y="4206240"/>
+            <a:off x="685800" y="3703320"/>
             <a:ext cx="7772400" cy="320040"/>
           </a:xfrm>
           <a:prstGeom prst="rect">
@@ -8361,9 +8497,48 @@
                 <a:ea typeface="Cambria" pitchFamily="34" charset="-122"/>
                 <a:cs typeface="Cambria" pitchFamily="34" charset="-120"/>
               </a:rPr>
-              <a:t>Only 56% of pauses longer than 200 ms follow punctuation: readers also pause mid-phrase.</a:t>
+              <a:t>Linear models fall 7 ms short: duration depends on feature interactions.</a:t>
             </a:r>
             <a:endParaRPr lang="en-US" sz="1500" dirty="0"/>
+          </a:p>
+        </p:txBody>
+      </p:sp>
+      <p:sp>
+        <p:nvSpPr>
+          <p:cNvPr id="9" name="Text 5"/>
+          <p:cNvSpPr txBox="1"/>
+          <p:nvPr/>
+        </p:nvSpPr>
+        <p:spPr>
+          <a:xfrm>
+            <a:off x="685800" y="4160520"/>
+            <a:ext cx="7772400" cy="274320"/>
+          </a:xfrm>
+          <a:prstGeom prst="rect">
+            <a:avLst/>
+          </a:prstGeom>
+          <a:noFill/>
+          <a:ln/>
+        </p:spPr>
+        <p:txBody>
+          <a:bodyPr wrap="square" lIns="0" tIns="0" rIns="0" bIns="0" rtlCol="0" anchor="ctr"/>
+          <a:lstStyle/>
+          <a:p>
+            <a:pPr indent="0" marL="0">
+              <a:buNone/>
+            </a:pPr>
+            <a:r>
+              <a:rPr lang="en-US" sz="1100" dirty="0">
+                <a:solidFill>
+                  <a:schemeClr val="accent3"/>
+                </a:solidFill>
+                <a:latin typeface="Calibri" pitchFamily="34" charset="0"/>
+                <a:ea typeface="Calibri" pitchFamily="34" charset="-122"/>
+                <a:cs typeface="Calibri" pitchFamily="34" charset="-120"/>
+              </a:rPr>
+              <a:t>LightGBM is significantly best for duration (paired CIs). Ablation: neighbours +5.7 ms and phoneme identity +5.0 ms matter most; the pause flag is redundant with the next phoneme.</a:t>
+            </a:r>
+            <a:endParaRPr lang="en-US" sz="1100" dirty="0"/>
           </a:p>
         </p:txBody>
       </p:sp>

</xml_diff>